<commit_message>
docs(tutorial): add pname-mapping slide to sFTP deck (where values come from)
Adds slide 5 to the codebase-analysis report.pptx pointing the migration
team at where each consumer's runtime parameter values live, without
exposing the values themselves in a committable artifact.

Per consumer: shows the literal `pname` the report uses to filter
`zfi_constants` plus the key fnam fields it reads. Values stay in
zfi_constants on the SAP system — migration team extracts them via
SE16 / SecureStorage through a secure handover channel, not through
this analysis output.

Why this is the right level: the analysis artifact lives in a private
repo but is still meant to be passed around between teams. Schema +
location is everything a migration planner needs; values are
operationally separated and ride a different channel.

Co-Authored-By: Claude Opus 4.7 (1M context) <noreply@anthropic.com>
</commit_message>
<xml_diff>
--- a/docs/tutorials/codebase-analysis/examples/report.pptx
+++ b/docs/tutorials/codebase-analysis/examples/report.pptx
@@ -9,6 +9,7 @@
     <p:sldId id="257" r:id="rId8"/>
     <p:sldId id="258" r:id="rId9"/>
     <p:sldId id="266" r:id="rId17"/>
+    <p:sldId id="267" r:id="rId18"/>
     <p:sldId id="259" r:id="rId10"/>
     <p:sldId id="260" r:id="rId11"/>
     <p:sldId id="261" r:id="rId12"/>
@@ -4233,6 +4234,1174 @@
             </a:pPr>
             <a:r>
               <a:t>Rises to ≈ 99% if customer confirms: 'all SFTP code lives in Z001 and reads zfi_constants'.</a:t>
+            </a:r>
+          </a:p>
+        </p:txBody>
+      </p:sp>
+    </p:spTree>
+  </p:cSld>
+  <p:clrMapOvr>
+    <a:masterClrMapping/>
+  </p:clrMapOvr>
+</p:sld>
+</file>
+
+<file path=ppt/slides/slide12.xml><?xml version="1.0" encoding="utf-8"?>
+<p:sld xmlns:a="http://schemas.openxmlformats.org/drawingml/2006/main" xmlns:p="http://schemas.openxmlformats.org/presentationml/2006/main" xmlns:r="http://schemas.openxmlformats.org/officeDocument/2006/relationships">
+  <p:cSld>
+    <p:spTree>
+      <p:nvGrpSpPr>
+        <p:cNvPr id="1" name=""/>
+        <p:cNvGrpSpPr/>
+        <p:nvPr/>
+      </p:nvGrpSpPr>
+      <p:grpSpPr/>
+      <p:sp>
+        <p:nvSpPr>
+          <p:cNvPr id="2" name="TextBox 1"/>
+          <p:cNvSpPr txBox="1"/>
+          <p:nvPr/>
+        </p:nvSpPr>
+        <p:spPr>
+          <a:xfrm>
+            <a:off x="457200" y="274320"/>
+            <a:ext cx="11247120" cy="822960"/>
+          </a:xfrm>
+          <a:prstGeom prst="rect">
+            <a:avLst/>
+          </a:prstGeom>
+          <a:noFill/>
+        </p:spPr>
+        <p:txBody>
+          <a:bodyPr wrap="none">
+            <a:spAutoFit/>
+          </a:bodyPr>
+          <a:lstStyle/>
+          <a:p>
+            <a:pPr>
+              <a:defRPr sz="2600" b="1">
+                <a:solidFill>
+                  <a:srgbClr val="1F3A68"/>
+                </a:solidFill>
+              </a:defRPr>
+            </a:pPr>
+            <a:r>
+              <a:t>Where SFTP parameter values come from</a:t>
+            </a:r>
+          </a:p>
+        </p:txBody>
+      </p:sp>
+      <p:sp>
+        <p:nvSpPr>
+          <p:cNvPr id="3" name="TextBox 2"/>
+          <p:cNvSpPr txBox="1"/>
+          <p:nvPr/>
+        </p:nvSpPr>
+        <p:spPr>
+          <a:xfrm>
+            <a:off x="457200" y="1005840"/>
+            <a:ext cx="11247120" cy="914400"/>
+          </a:xfrm>
+          <a:prstGeom prst="rect">
+            <a:avLst/>
+          </a:prstGeom>
+          <a:noFill/>
+        </p:spPr>
+        <p:txBody>
+          <a:bodyPr wrap="square">
+            <a:spAutoFit/>
+          </a:bodyPr>
+          <a:lstStyle/>
+          <a:p>
+            <a:pPr>
+              <a:defRPr sz="1400" b="0">
+                <a:solidFill>
+                  <a:srgbClr val="C83636"/>
+                </a:solidFill>
+              </a:defRPr>
+            </a:pPr>
+            <a:r>
+              <a:t>All parameter values (credentials, hosts, ports, paths) live in table `zfi_constants`.</a:t>
+            </a:r>
+          </a:p>
+          <a:p>
+            <a:pPr>
+              <a:defRPr sz="1400" b="0">
+                <a:solidFill>
+                  <a:srgbClr val="C83636"/>
+                </a:solidFill>
+              </a:defRPr>
+            </a:pPr>
+            <a:r>
+              <a:t>Each consumer reads a specific `pname` and pulls its fnam → fval pairs at runtime.</a:t>
+            </a:r>
+          </a:p>
+          <a:p>
+            <a:pPr>
+              <a:defRPr sz="1400" b="0">
+                <a:solidFill>
+                  <a:srgbClr val="C83636"/>
+                </a:solidFill>
+              </a:defRPr>
+            </a:pPr>
+            <a:r>
+              <a:t>Values are NOT shown here — fetch from SE16 / SecureStorage via the Basis team for migration handoff.</a:t>
+            </a:r>
+          </a:p>
+        </p:txBody>
+      </p:sp>
+      <p:graphicFrame>
+        <p:nvGraphicFramePr>
+          <p:cNvPr id="4" name="Table 3"/>
+          <p:cNvGraphicFramePr>
+            <a:graphicFrameLocks noGrp="1"/>
+          </p:cNvGraphicFramePr>
+          <p:nvPr/>
+        </p:nvGraphicFramePr>
+        <p:xfrm>
+          <a:off x="365760" y="2194560"/>
+          <a:ext cx="11430000" cy="4389120"/>
+        </p:xfrm>
+        <a:graphic>
+          <a:graphicData uri="http://schemas.openxmlformats.org/drawingml/2006/table">
+            <a:tbl>
+              <a:tblPr firstRow="1" bandRow="1">
+                <a:tableStyleId>{5C22544A-7EE6-4342-B048-85BDC9FD1C3A}</a:tableStyleId>
+              </a:tblPr>
+              <a:tblGrid>
+                <a:gridCol w="3200400"/>
+                <a:gridCol w="2926080"/>
+                <a:gridCol w="5303520"/>
+              </a:tblGrid>
+              <a:tr h="313508">
+                <a:tc>
+                  <a:txBody>
+                    <a:bodyPr/>
+                    <a:lstStyle/>
+                    <a:p>
+                      <a:pPr>
+                        <a:defRPr sz="1100" b="1">
+                          <a:solidFill>
+                            <a:srgbClr val="FFFFFF"/>
+                          </a:solidFill>
+                        </a:defRPr>
+                      </a:pPr>
+                      <a:r>
+                        <a:t>Consumer (PROG / FUGR)</a:t>
+                      </a:r>
+                    </a:p>
+                  </a:txBody>
+                  <a:tcPr>
+                    <a:solidFill>
+                      <a:srgbClr val="1F3A68"/>
+                    </a:solidFill>
+                  </a:tcPr>
+                </a:tc>
+                <a:tc>
+                  <a:txBody>
+                    <a:bodyPr/>
+                    <a:lstStyle/>
+                    <a:p>
+                      <a:pPr>
+                        <a:defRPr sz="1100" b="1">
+                          <a:solidFill>
+                            <a:srgbClr val="FFFFFF"/>
+                          </a:solidFill>
+                        </a:defRPr>
+                      </a:pPr>
+                      <a:r>
+                        <a:t>pname filter used</a:t>
+                      </a:r>
+                    </a:p>
+                  </a:txBody>
+                  <a:tcPr>
+                    <a:solidFill>
+                      <a:srgbClr val="1F3A68"/>
+                    </a:solidFill>
+                  </a:tcPr>
+                </a:tc>
+                <a:tc>
+                  <a:txBody>
+                    <a:bodyPr/>
+                    <a:lstStyle/>
+                    <a:p>
+                      <a:pPr>
+                        <a:defRPr sz="1100" b="1">
+                          <a:solidFill>
+                            <a:srgbClr val="FFFFFF"/>
+                          </a:solidFill>
+                        </a:defRPr>
+                      </a:pPr>
+                      <a:r>
+                        <a:t>Key fnam fields read</a:t>
+                      </a:r>
+                    </a:p>
+                  </a:txBody>
+                  <a:tcPr>
+                    <a:solidFill>
+                      <a:srgbClr val="1F3A68"/>
+                    </a:solidFill>
+                  </a:tcPr>
+                </a:tc>
+              </a:tr>
+              <a:tr h="313508">
+                <a:tc>
+                  <a:txBody>
+                    <a:bodyPr/>
+                    <a:lstStyle/>
+                    <a:p>
+                      <a:pPr>
+                        <a:defRPr sz="1000">
+                          <a:solidFill>
+                            <a:srgbClr val="333333"/>
+                          </a:solidFill>
+                        </a:defRPr>
+                      </a:pPr>
+                      <a:r>
+                        <a:t>ZSFTP_CITI_PULL</a:t>
+                      </a:r>
+                    </a:p>
+                  </a:txBody>
+                  <a:tcPr>
+                    <a:solidFill>
+                      <a:srgbClr val="FFFFFF"/>
+                    </a:solidFill>
+                  </a:tcPr>
+                </a:tc>
+                <a:tc>
+                  <a:txBody>
+                    <a:bodyPr/>
+                    <a:lstStyle/>
+                    <a:p>
+                      <a:pPr>
+                        <a:defRPr sz="1000">
+                          <a:solidFill>
+                            <a:srgbClr val="333333"/>
+                          </a:solidFill>
+                        </a:defRPr>
+                      </a:pPr>
+                      <a:r>
+                        <a:t>'ZSFTP_CITI'</a:t>
+                      </a:r>
+                    </a:p>
+                  </a:txBody>
+                  <a:tcPr>
+                    <a:solidFill>
+                      <a:srgbClr val="FFFFFF"/>
+                    </a:solidFill>
+                  </a:tcPr>
+                </a:tc>
+                <a:tc>
+                  <a:txBody>
+                    <a:bodyPr/>
+                    <a:lstStyle/>
+                    <a:p>
+                      <a:pPr>
+                        <a:defRPr sz="1000">
+                          <a:solidFill>
+                            <a:srgbClr val="333333"/>
+                          </a:solidFill>
+                        </a:defRPr>
+                      </a:pPr>
+                      <a:r>
+                        <a:t>FTP_USER, FTP_DOMAIN, HOST_KEY, PRIVATE_KEY_PATH, PASSPHRASE, SOURCE_FOLDER</a:t>
+                      </a:r>
+                    </a:p>
+                  </a:txBody>
+                  <a:tcPr>
+                    <a:solidFill>
+                      <a:srgbClr val="FFFFFF"/>
+                    </a:solidFill>
+                  </a:tcPr>
+                </a:tc>
+              </a:tr>
+              <a:tr h="313508">
+                <a:tc>
+                  <a:txBody>
+                    <a:bodyPr/>
+                    <a:lstStyle/>
+                    <a:p>
+                      <a:pPr>
+                        <a:defRPr sz="1000">
+                          <a:solidFill>
+                            <a:srgbClr val="333333"/>
+                          </a:solidFill>
+                        </a:defRPr>
+                      </a:pPr>
+                      <a:r>
+                        <a:t>ZSFTP_CITI_SEND</a:t>
+                      </a:r>
+                    </a:p>
+                  </a:txBody>
+                  <a:tcPr>
+                    <a:solidFill>
+                      <a:srgbClr val="F0F2F7"/>
+                    </a:solidFill>
+                  </a:tcPr>
+                </a:tc>
+                <a:tc>
+                  <a:txBody>
+                    <a:bodyPr/>
+                    <a:lstStyle/>
+                    <a:p>
+                      <a:pPr>
+                        <a:defRPr sz="1000">
+                          <a:solidFill>
+                            <a:srgbClr val="333333"/>
+                          </a:solidFill>
+                        </a:defRPr>
+                      </a:pPr>
+                      <a:r>
+                        <a:t>'ZSFTP_CITI_SEND'</a:t>
+                      </a:r>
+                    </a:p>
+                  </a:txBody>
+                  <a:tcPr>
+                    <a:solidFill>
+                      <a:srgbClr val="F0F2F7"/>
+                    </a:solidFill>
+                  </a:tcPr>
+                </a:tc>
+                <a:tc>
+                  <a:txBody>
+                    <a:bodyPr/>
+                    <a:lstStyle/>
+                    <a:p>
+                      <a:pPr>
+                        <a:defRPr sz="1000">
+                          <a:solidFill>
+                            <a:srgbClr val="333333"/>
+                          </a:solidFill>
+                        </a:defRPr>
+                      </a:pPr>
+                      <a:r>
+                        <a:t>(same shape as ZSFTP_CITI)</a:t>
+                      </a:r>
+                    </a:p>
+                  </a:txBody>
+                  <a:tcPr>
+                    <a:solidFill>
+                      <a:srgbClr val="F0F2F7"/>
+                    </a:solidFill>
+                  </a:tcPr>
+                </a:tc>
+              </a:tr>
+              <a:tr h="313508">
+                <a:tc>
+                  <a:txBody>
+                    <a:bodyPr/>
+                    <a:lstStyle/>
+                    <a:p>
+                      <a:pPr>
+                        <a:defRPr sz="1000">
+                          <a:solidFill>
+                            <a:srgbClr val="333333"/>
+                          </a:solidFill>
+                        </a:defRPr>
+                      </a:pPr>
+                      <a:r>
+                        <a:t>ZSFTP_BNP_PARIBAS_PULL</a:t>
+                      </a:r>
+                    </a:p>
+                  </a:txBody>
+                  <a:tcPr>
+                    <a:solidFill>
+                      <a:srgbClr val="FFFFFF"/>
+                    </a:solidFill>
+                  </a:tcPr>
+                </a:tc>
+                <a:tc>
+                  <a:txBody>
+                    <a:bodyPr/>
+                    <a:lstStyle/>
+                    <a:p>
+                      <a:pPr>
+                        <a:defRPr sz="1000">
+                          <a:solidFill>
+                            <a:srgbClr val="333333"/>
+                          </a:solidFill>
+                        </a:defRPr>
+                      </a:pPr>
+                      <a:r>
+                        <a:t>'ZSFTP_BNP_PARIBAS'</a:t>
+                      </a:r>
+                    </a:p>
+                  </a:txBody>
+                  <a:tcPr>
+                    <a:solidFill>
+                      <a:srgbClr val="FFFFFF"/>
+                    </a:solidFill>
+                  </a:tcPr>
+                </a:tc>
+                <a:tc>
+                  <a:txBody>
+                    <a:bodyPr/>
+                    <a:lstStyle/>
+                    <a:p>
+                      <a:pPr>
+                        <a:defRPr sz="1000">
+                          <a:solidFill>
+                            <a:srgbClr val="333333"/>
+                          </a:solidFill>
+                        </a:defRPr>
+                      </a:pPr>
+                      <a:r>
+                        <a:t>FTP_USER, FTP_PSWD, FTP_DOMAIN, FTP_PORT, FOLDER_PATH, FILE_EXT, HOST_KEY</a:t>
+                      </a:r>
+                    </a:p>
+                  </a:txBody>
+                  <a:tcPr>
+                    <a:solidFill>
+                      <a:srgbClr val="FFFFFF"/>
+                    </a:solidFill>
+                  </a:tcPr>
+                </a:tc>
+              </a:tr>
+              <a:tr h="313508">
+                <a:tc>
+                  <a:txBody>
+                    <a:bodyPr/>
+                    <a:lstStyle/>
+                    <a:p>
+                      <a:pPr>
+                        <a:defRPr sz="1000">
+                          <a:solidFill>
+                            <a:srgbClr val="333333"/>
+                          </a:solidFill>
+                        </a:defRPr>
+                      </a:pPr>
+                      <a:r>
+                        <a:t>ZSFTP_BNP_PARIBAS (push, password)</a:t>
+                      </a:r>
+                    </a:p>
+                  </a:txBody>
+                  <a:tcPr>
+                    <a:solidFill>
+                      <a:srgbClr val="F0F2F7"/>
+                    </a:solidFill>
+                  </a:tcPr>
+                </a:tc>
+                <a:tc>
+                  <a:txBody>
+                    <a:bodyPr/>
+                    <a:lstStyle/>
+                    <a:p>
+                      <a:pPr>
+                        <a:defRPr sz="1000">
+                          <a:solidFill>
+                            <a:srgbClr val="333333"/>
+                          </a:solidFill>
+                        </a:defRPr>
+                      </a:pPr>
+                      <a:r>
+                        <a:t>'ZSFTP_BNP_PARIBAS'</a:t>
+                      </a:r>
+                    </a:p>
+                  </a:txBody>
+                  <a:tcPr>
+                    <a:solidFill>
+                      <a:srgbClr val="F0F2F7"/>
+                    </a:solidFill>
+                  </a:tcPr>
+                </a:tc>
+                <a:tc>
+                  <a:txBody>
+                    <a:bodyPr/>
+                    <a:lstStyle/>
+                    <a:p>
+                      <a:pPr>
+                        <a:defRPr sz="1000">
+                          <a:solidFill>
+                            <a:srgbClr val="333333"/>
+                          </a:solidFill>
+                        </a:defRPr>
+                      </a:pPr>
+                      <a:r>
+                        <a:t>Same set as above (password auth)</a:t>
+                      </a:r>
+                    </a:p>
+                  </a:txBody>
+                  <a:tcPr>
+                    <a:solidFill>
+                      <a:srgbClr val="F0F2F7"/>
+                    </a:solidFill>
+                  </a:tcPr>
+                </a:tc>
+              </a:tr>
+              <a:tr h="313508">
+                <a:tc>
+                  <a:txBody>
+                    <a:bodyPr/>
+                    <a:lstStyle/>
+                    <a:p>
+                      <a:pPr>
+                        <a:defRPr sz="1000">
+                          <a:solidFill>
+                            <a:srgbClr val="333333"/>
+                          </a:solidFill>
+                        </a:defRPr>
+                      </a:pPr>
+                      <a:r>
+                        <a:t>ZSFTP_BNP_PARIBAS_WITH_PGP</a:t>
+                      </a:r>
+                    </a:p>
+                  </a:txBody>
+                  <a:tcPr>
+                    <a:solidFill>
+                      <a:srgbClr val="FFFFFF"/>
+                    </a:solidFill>
+                  </a:tcPr>
+                </a:tc>
+                <a:tc>
+                  <a:txBody>
+                    <a:bodyPr/>
+                    <a:lstStyle/>
+                    <a:p>
+                      <a:pPr>
+                        <a:defRPr sz="1000">
+                          <a:solidFill>
+                            <a:srgbClr val="333333"/>
+                          </a:solidFill>
+                        </a:defRPr>
+                      </a:pPr>
+                      <a:r>
+                        <a:t>'ZSFTP_BNP_PARIBAS'</a:t>
+                      </a:r>
+                    </a:p>
+                  </a:txBody>
+                  <a:tcPr>
+                    <a:solidFill>
+                      <a:srgbClr val="FFFFFF"/>
+                    </a:solidFill>
+                  </a:tcPr>
+                </a:tc>
+                <a:tc>
+                  <a:txBody>
+                    <a:bodyPr/>
+                    <a:lstStyle/>
+                    <a:p>
+                      <a:pPr>
+                        <a:defRPr sz="1000">
+                          <a:solidFill>
+                            <a:srgbClr val="333333"/>
+                          </a:solidFill>
+                        </a:defRPr>
+                      </a:pPr>
+                      <a:r>
+                        <a:t>FTP_USER, FTP_DOMAIN, HOST_KEY, PRIVATE_KEY_PATH, PASSPHRASE, FOLDER_PATH (PGP layer added)</a:t>
+                      </a:r>
+                    </a:p>
+                  </a:txBody>
+                  <a:tcPr>
+                    <a:solidFill>
+                      <a:srgbClr val="FFFFFF"/>
+                    </a:solidFill>
+                  </a:tcPr>
+                </a:tc>
+              </a:tr>
+              <a:tr h="313508">
+                <a:tc>
+                  <a:txBody>
+                    <a:bodyPr/>
+                    <a:lstStyle/>
+                    <a:p>
+                      <a:pPr>
+                        <a:defRPr sz="1000">
+                          <a:solidFill>
+                            <a:srgbClr val="333333"/>
+                          </a:solidFill>
+                        </a:defRPr>
+                      </a:pPr>
+                      <a:r>
+                        <a:t>ZSFTP_CAPARIO_PULL</a:t>
+                      </a:r>
+                    </a:p>
+                  </a:txBody>
+                  <a:tcPr>
+                    <a:solidFill>
+                      <a:srgbClr val="F0F2F7"/>
+                    </a:solidFill>
+                  </a:tcPr>
+                </a:tc>
+                <a:tc>
+                  <a:txBody>
+                    <a:bodyPr/>
+                    <a:lstStyle/>
+                    <a:p>
+                      <a:pPr>
+                        <a:defRPr sz="1000">
+                          <a:solidFill>
+                            <a:srgbClr val="333333"/>
+                          </a:solidFill>
+                        </a:defRPr>
+                      </a:pPr>
+                      <a:r>
+                        <a:t>'ZSFTP_835_PULL'</a:t>
+                      </a:r>
+                    </a:p>
+                  </a:txBody>
+                  <a:tcPr>
+                    <a:solidFill>
+                      <a:srgbClr val="F0F2F7"/>
+                    </a:solidFill>
+                  </a:tcPr>
+                </a:tc>
+                <a:tc>
+                  <a:txBody>
+                    <a:bodyPr/>
+                    <a:lstStyle/>
+                    <a:p>
+                      <a:pPr>
+                        <a:defRPr sz="1000">
+                          <a:solidFill>
+                            <a:srgbClr val="333333"/>
+                          </a:solidFill>
+                        </a:defRPr>
+                      </a:pPr>
+                      <a:r>
+                        <a:t>Standard key-auth bundle + FOLDER_PATH + FILE_EXT</a:t>
+                      </a:r>
+                    </a:p>
+                  </a:txBody>
+                  <a:tcPr>
+                    <a:solidFill>
+                      <a:srgbClr val="F0F2F7"/>
+                    </a:solidFill>
+                  </a:tcPr>
+                </a:tc>
+              </a:tr>
+              <a:tr h="313508">
+                <a:tc>
+                  <a:txBody>
+                    <a:bodyPr/>
+                    <a:lstStyle/>
+                    <a:p>
+                      <a:pPr>
+                        <a:defRPr sz="1000">
+                          <a:solidFill>
+                            <a:srgbClr val="333333"/>
+                          </a:solidFill>
+                        </a:defRPr>
+                      </a:pPr>
+                      <a:r>
+                        <a:t>ZSFTP_CAPARIO</a:t>
+                      </a:r>
+                    </a:p>
+                  </a:txBody>
+                  <a:tcPr>
+                    <a:solidFill>
+                      <a:srgbClr val="FFFFFF"/>
+                    </a:solidFill>
+                  </a:tcPr>
+                </a:tc>
+                <a:tc>
+                  <a:txBody>
+                    <a:bodyPr/>
+                    <a:lstStyle/>
+                    <a:p>
+                      <a:pPr>
+                        <a:defRPr sz="1000">
+                          <a:solidFill>
+                            <a:srgbClr val="333333"/>
+                          </a:solidFill>
+                        </a:defRPr>
+                      </a:pPr>
+                      <a:r>
+                        <a:t>'ZSFTP_837'</a:t>
+                      </a:r>
+                    </a:p>
+                  </a:txBody>
+                  <a:tcPr>
+                    <a:solidFill>
+                      <a:srgbClr val="FFFFFF"/>
+                    </a:solidFill>
+                  </a:tcPr>
+                </a:tc>
+                <a:tc>
+                  <a:txBody>
+                    <a:bodyPr/>
+                    <a:lstStyle/>
+                    <a:p>
+                      <a:pPr>
+                        <a:defRPr sz="1000">
+                          <a:solidFill>
+                            <a:srgbClr val="333333"/>
+                          </a:solidFill>
+                        </a:defRPr>
+                      </a:pPr>
+                      <a:r>
+                        <a:t>Standard key-auth bundle (push)</a:t>
+                      </a:r>
+                    </a:p>
+                  </a:txBody>
+                  <a:tcPr>
+                    <a:solidFill>
+                      <a:srgbClr val="FFFFFF"/>
+                    </a:solidFill>
+                  </a:tcPr>
+                </a:tc>
+              </a:tr>
+              <a:tr h="313508">
+                <a:tc>
+                  <a:txBody>
+                    <a:bodyPr/>
+                    <a:lstStyle/>
+                    <a:p>
+                      <a:pPr>
+                        <a:defRPr sz="1000">
+                          <a:solidFill>
+                            <a:srgbClr val="333333"/>
+                          </a:solidFill>
+                        </a:defRPr>
+                      </a:pPr>
+                      <a:r>
+                        <a:t>ZSFTP_PATIENTCO_PULL</a:t>
+                      </a:r>
+                    </a:p>
+                  </a:txBody>
+                  <a:tcPr>
+                    <a:solidFill>
+                      <a:srgbClr val="F0F2F7"/>
+                    </a:solidFill>
+                  </a:tcPr>
+                </a:tc>
+                <a:tc>
+                  <a:txBody>
+                    <a:bodyPr/>
+                    <a:lstStyle/>
+                    <a:p>
+                      <a:pPr>
+                        <a:defRPr sz="1000">
+                          <a:solidFill>
+                            <a:srgbClr val="333333"/>
+                          </a:solidFill>
+                        </a:defRPr>
+                      </a:pPr>
+                      <a:r>
+                        <a:t>'ZSFTP_835_PATIENTCO'</a:t>
+                      </a:r>
+                    </a:p>
+                  </a:txBody>
+                  <a:tcPr>
+                    <a:solidFill>
+                      <a:srgbClr val="F0F2F7"/>
+                    </a:solidFill>
+                  </a:tcPr>
+                </a:tc>
+                <a:tc>
+                  <a:txBody>
+                    <a:bodyPr/>
+                    <a:lstStyle/>
+                    <a:p>
+                      <a:pPr>
+                        <a:defRPr sz="1000">
+                          <a:solidFill>
+                            <a:srgbClr val="333333"/>
+                          </a:solidFill>
+                        </a:defRPr>
+                      </a:pPr>
+                      <a:r>
+                        <a:t>FTP_USER, FTP_DOMAIN, HOST_KEY, FTP_PSWD (fallback), FOLDER_PATH, FILE_EXT</a:t>
+                      </a:r>
+                    </a:p>
+                  </a:txBody>
+                  <a:tcPr>
+                    <a:solidFill>
+                      <a:srgbClr val="F0F2F7"/>
+                    </a:solidFill>
+                  </a:tcPr>
+                </a:tc>
+              </a:tr>
+              <a:tr h="313508">
+                <a:tc>
+                  <a:txBody>
+                    <a:bodyPr/>
+                    <a:lstStyle/>
+                    <a:p>
+                      <a:pPr>
+                        <a:defRPr sz="1000">
+                          <a:solidFill>
+                            <a:srgbClr val="333333"/>
+                          </a:solidFill>
+                        </a:defRPr>
+                      </a:pPr>
+                      <a:r>
+                        <a:t>ZSFTP_JPM / ZSFTP_JPM_PULL</a:t>
+                      </a:r>
+                    </a:p>
+                  </a:txBody>
+                  <a:tcPr>
+                    <a:solidFill>
+                      <a:srgbClr val="FFFFFF"/>
+                    </a:solidFill>
+                  </a:tcPr>
+                </a:tc>
+                <a:tc>
+                  <a:txBody>
+                    <a:bodyPr/>
+                    <a:lstStyle/>
+                    <a:p>
+                      <a:pPr>
+                        <a:defRPr sz="1000">
+                          <a:solidFill>
+                            <a:srgbClr val="333333"/>
+                          </a:solidFill>
+                        </a:defRPr>
+                      </a:pPr>
+                      <a:r>
+                        <a:t>'ZSFTP_JPM'</a:t>
+                      </a:r>
+                    </a:p>
+                  </a:txBody>
+                  <a:tcPr>
+                    <a:solidFill>
+                      <a:srgbClr val="FFFFFF"/>
+                    </a:solidFill>
+                  </a:tcPr>
+                </a:tc>
+                <a:tc>
+                  <a:txBody>
+                    <a:bodyPr/>
+                    <a:lstStyle/>
+                    <a:p>
+                      <a:pPr>
+                        <a:defRPr sz="1000">
+                          <a:solidFill>
+                            <a:srgbClr val="333333"/>
+                          </a:solidFill>
+                        </a:defRPr>
+                      </a:pPr>
+                      <a:r>
+                        <a:t>Standard key-auth bundle</a:t>
+                      </a:r>
+                    </a:p>
+                  </a:txBody>
+                  <a:tcPr>
+                    <a:solidFill>
+                      <a:srgbClr val="FFFFFF"/>
+                    </a:solidFill>
+                  </a:tcPr>
+                </a:tc>
+              </a:tr>
+              <a:tr h="313508">
+                <a:tc>
+                  <a:txBody>
+                    <a:bodyPr/>
+                    <a:lstStyle/>
+                    <a:p>
+                      <a:pPr>
+                        <a:defRPr sz="1000">
+                          <a:solidFill>
+                            <a:srgbClr val="333333"/>
+                          </a:solidFill>
+                        </a:defRPr>
+                      </a:pPr>
+                      <a:r>
+                        <a:t>ZFFIU_ACC_POST / ZSFTP_CERIDIAN_PULL</a:t>
+                      </a:r>
+                    </a:p>
+                  </a:txBody>
+                  <a:tcPr>
+                    <a:solidFill>
+                      <a:srgbClr val="F0F2F7"/>
+                    </a:solidFill>
+                  </a:tcPr>
+                </a:tc>
+                <a:tc>
+                  <a:txBody>
+                    <a:bodyPr/>
+                    <a:lstStyle/>
+                    <a:p>
+                      <a:pPr>
+                        <a:defRPr sz="1000">
+                          <a:solidFill>
+                            <a:srgbClr val="333333"/>
+                          </a:solidFill>
+                        </a:defRPr>
+                      </a:pPr>
+                      <a:r>
+                        <a:t>'ZSFTP_CERIDIAN'</a:t>
+                      </a:r>
+                    </a:p>
+                  </a:txBody>
+                  <a:tcPr>
+                    <a:solidFill>
+                      <a:srgbClr val="F0F2F7"/>
+                    </a:solidFill>
+                  </a:tcPr>
+                </a:tc>
+                <a:tc>
+                  <a:txBody>
+                    <a:bodyPr/>
+                    <a:lstStyle/>
+                    <a:p>
+                      <a:pPr>
+                        <a:defRPr sz="1000">
+                          <a:solidFill>
+                            <a:srgbClr val="333333"/>
+                          </a:solidFill>
+                        </a:defRPr>
+                      </a:pPr>
+                      <a:r>
+                        <a:t>FTP_USER, FTP_DOMAIN, HOST_KEY, PASSPHRASE, SFTP_FILE_EXT, SOURCE_FOLDER</a:t>
+                      </a:r>
+                    </a:p>
+                  </a:txBody>
+                  <a:tcPr>
+                    <a:solidFill>
+                      <a:srgbClr val="F0F2F7"/>
+                    </a:solidFill>
+                  </a:tcPr>
+                </a:tc>
+              </a:tr>
+              <a:tr h="313508">
+                <a:tc>
+                  <a:txBody>
+                    <a:bodyPr/>
+                    <a:lstStyle/>
+                    <a:p>
+                      <a:pPr>
+                        <a:defRPr sz="1000">
+                          <a:solidFill>
+                            <a:srgbClr val="333333"/>
+                          </a:solidFill>
+                        </a:defRPr>
+                      </a:pPr>
+                      <a:r>
+                        <a:t>ZDMS_UPLOAD_FILES / ZDMS_REPLACE_FILES</a:t>
+                      </a:r>
+                    </a:p>
+                  </a:txBody>
+                  <a:tcPr>
+                    <a:solidFill>
+                      <a:srgbClr val="FFFFFF"/>
+                    </a:solidFill>
+                  </a:tcPr>
+                </a:tc>
+                <a:tc>
+                  <a:txBody>
+                    <a:bodyPr/>
+                    <a:lstStyle/>
+                    <a:p>
+                      <a:pPr>
+                        <a:defRPr sz="1000">
+                          <a:solidFill>
+                            <a:srgbClr val="333333"/>
+                          </a:solidFill>
+                        </a:defRPr>
+                      </a:pPr>
+                      <a:r>
+                        <a:t>(GET) 'ZSFTP_DMS_IN' + (PUT) 'ZSFTP_DMS_OUT'</a:t>
+                      </a:r>
+                    </a:p>
+                  </a:txBody>
+                  <a:tcPr>
+                    <a:solidFill>
+                      <a:srgbClr val="FFFFFF"/>
+                    </a:solidFill>
+                  </a:tcPr>
+                </a:tc>
+                <a:tc>
+                  <a:txBody>
+                    <a:bodyPr/>
+                    <a:lstStyle/>
+                    <a:p>
+                      <a:pPr>
+                        <a:defRPr sz="1000">
+                          <a:solidFill>
+                            <a:srgbClr val="333333"/>
+                          </a:solidFill>
+                        </a:defRPr>
+                      </a:pPr>
+                      <a:r>
+                        <a:t>Standard key-auth bundle + SOURCE_FOLDER + ZDEST_FOLD</a:t>
+                      </a:r>
+                    </a:p>
+                  </a:txBody>
+                  <a:tcPr>
+                    <a:solidFill>
+                      <a:srgbClr val="FFFFFF"/>
+                    </a:solidFill>
+                  </a:tcPr>
+                </a:tc>
+              </a:tr>
+              <a:tr h="313508">
+                <a:tc>
+                  <a:txBody>
+                    <a:bodyPr/>
+                    <a:lstStyle/>
+                    <a:p>
+                      <a:pPr>
+                        <a:defRPr sz="1000">
+                          <a:solidFill>
+                            <a:srgbClr val="333333"/>
+                          </a:solidFill>
+                        </a:defRPr>
+                      </a:pPr>
+                      <a:r>
+                        <a:t>ZSD_MEDICARE_PDF_PROCESS (via ZMEDI)</a:t>
+                      </a:r>
+                    </a:p>
+                  </a:txBody>
+                  <a:tcPr>
+                    <a:solidFill>
+                      <a:srgbClr val="F0F2F7"/>
+                    </a:solidFill>
+                  </a:tcPr>
+                </a:tc>
+                <a:tc>
+                  <a:txBody>
+                    <a:bodyPr/>
+                    <a:lstStyle/>
+                    <a:p>
+                      <a:pPr>
+                        <a:defRPr sz="1000">
+                          <a:solidFill>
+                            <a:srgbClr val="333333"/>
+                          </a:solidFill>
+                        </a:defRPr>
+                      </a:pPr>
+                      <a:r>
+                        <a:t>'ZSFTP_MEDICARE_IN' + 'ZSFTP_MEDICARE_OUT'</a:t>
+                      </a:r>
+                    </a:p>
+                  </a:txBody>
+                  <a:tcPr>
+                    <a:solidFill>
+                      <a:srgbClr val="F0F2F7"/>
+                    </a:solidFill>
+                  </a:tcPr>
+                </a:tc>
+                <a:tc>
+                  <a:txBody>
+                    <a:bodyPr/>
+                    <a:lstStyle/>
+                    <a:p>
+                      <a:pPr>
+                        <a:defRPr sz="1000">
+                          <a:solidFill>
+                            <a:srgbClr val="333333"/>
+                          </a:solidFill>
+                        </a:defRPr>
+                      </a:pPr>
+                      <a:r>
+                        <a:t>FTP_USER, PASSPHRASE, HOST_KEY, FTP_DOMAIN, PRIVATE_KEY_PATH, SOURCE_PATH, ZDEST_FOLD</a:t>
+                      </a:r>
+                    </a:p>
+                  </a:txBody>
+                  <a:tcPr>
+                    <a:solidFill>
+                      <a:srgbClr val="F0F2F7"/>
+                    </a:solidFill>
+                  </a:tcPr>
+                </a:tc>
+              </a:tr>
+              <a:tr h="313516">
+                <a:tc>
+                  <a:txBody>
+                    <a:bodyPr/>
+                    <a:lstStyle/>
+                    <a:p>
+                      <a:pPr>
+                        <a:defRPr sz="1000">
+                          <a:solidFill>
+                            <a:srgbClr val="333333"/>
+                          </a:solidFill>
+                        </a:defRPr>
+                      </a:pPr>
+                      <a:r>
+                        <a:t>ZSD_ERX_DMS_FILE_PROCESS (via ZERX)</a:t>
+                      </a:r>
+                    </a:p>
+                  </a:txBody>
+                  <a:tcPr>
+                    <a:solidFill>
+                      <a:srgbClr val="FFFFFF"/>
+                    </a:solidFill>
+                  </a:tcPr>
+                </a:tc>
+                <a:tc>
+                  <a:txBody>
+                    <a:bodyPr/>
+                    <a:lstStyle/>
+                    <a:p>
+                      <a:pPr>
+                        <a:defRPr sz="1000">
+                          <a:solidFill>
+                            <a:srgbClr val="333333"/>
+                          </a:solidFill>
+                        </a:defRPr>
+                      </a:pPr>
+                      <a:r>
+                        <a:t>(via ZERX wrapper FUGR)</a:t>
+                      </a:r>
+                    </a:p>
+                  </a:txBody>
+                  <a:tcPr>
+                    <a:solidFill>
+                      <a:srgbClr val="FFFFFF"/>
+                    </a:solidFill>
+                  </a:tcPr>
+                </a:tc>
+                <a:tc>
+                  <a:txBody>
+                    <a:bodyPr/>
+                    <a:lstStyle/>
+                    <a:p>
+                      <a:pPr>
+                        <a:defRPr sz="1000">
+                          <a:solidFill>
+                            <a:srgbClr val="333333"/>
+                          </a:solidFill>
+                        </a:defRPr>
+                      </a:pPr>
+                      <a:r>
+                        <a:t>Standard key-auth bundle</a:t>
+                      </a:r>
+                    </a:p>
+                  </a:txBody>
+                  <a:tcPr>
+                    <a:solidFill>
+                      <a:srgbClr val="FFFFFF"/>
+                    </a:solidFill>
+                  </a:tcPr>
+                </a:tc>
+              </a:tr>
+            </a:tbl>
+          </a:graphicData>
+        </a:graphic>
+      </p:graphicFrame>
+      <p:sp>
+        <p:nvSpPr>
+          <p:cNvPr id="5" name="TextBox 4"/>
+          <p:cNvSpPr txBox="1"/>
+          <p:nvPr/>
+        </p:nvSpPr>
+        <p:spPr>
+          <a:xfrm>
+            <a:off x="457200" y="6675120"/>
+            <a:ext cx="11247120" cy="182880"/>
+          </a:xfrm>
+          <a:prstGeom prst="rect">
+            <a:avLst/>
+          </a:prstGeom>
+          <a:noFill/>
+        </p:spPr>
+        <p:txBody>
+          <a:bodyPr wrap="square">
+            <a:spAutoFit/>
+          </a:bodyPr>
+          <a:lstStyle/>
+          <a:p>
+            <a:pPr>
+              <a:defRPr sz="1000" b="1">
+                <a:solidFill>
+                  <a:srgbClr val="1F3A68"/>
+                </a:solidFill>
+              </a:defRPr>
+            </a:pPr>
+            <a:r>
+              <a:t>Migration handoff: extract zfi_constants rows for these pnames into the new credential store; do not include the values in any code-review / analysis artifact.</a:t>
             </a:r>
           </a:p>
         </p:txBody>

</xml_diff>